<commit_message>
GCG June: Azerion vendor data integrated (58 apps +35% @ $510; starts-quality fix; US-only geo); deck/sheet/billable updated in place
Co-Authored-By: Claude Fable 5 <noreply@anthropic.com>
</commit_message>
<xml_diff>
--- a/report-client-decks/06. GCG_US_June_2026_Performance_Review.pptx
+++ b/report-client-decks/06. GCG_US_June_2026_Performance_Review.pptx
@@ -9157,7 +9157,7 @@
                 </a:solidFill>
                 <a:latin typeface="Arial"/>
               </a:rPr>
-              <a:t>AZERION &amp; NATIVE</a:t>
+              <a:t>AZERION  ·  PERFORMANCE &amp; READ</a:t>
             </a:r>
           </a:p>
         </p:txBody>
@@ -9192,7 +9192,7 @@
                 </a:solidFill>
                 <a:latin typeface="Arial"/>
               </a:rPr>
-              <a:t>The largest converter and the newest pilot report with the vendor files.</a:t>
+              <a:t>58 applications, up 35% on a 12% budget increase. Fewer starts, better starts.</a:t>
             </a:r>
           </a:p>
         </p:txBody>
@@ -9320,7 +9320,7 @@
         <p:spPr>
           <a:xfrm>
             <a:off x="457200" y="1737360"/>
-            <a:ext cx="2194560" cy="1005840"/>
+            <a:ext cx="1737360" cy="1005840"/>
           </a:xfrm>
           <a:prstGeom prst="rect">
             <a:avLst/>
@@ -9408,7 +9408,7 @@
         <p:spPr>
           <a:xfrm>
             <a:off x="640080" y="1783080"/>
-            <a:ext cx="1920240" cy="274320"/>
+            <a:ext cx="1463039" cy="274320"/>
           </a:xfrm>
           <a:prstGeom prst="rect">
             <a:avLst/>
@@ -9429,7 +9429,7 @@
                 </a:solidFill>
                 <a:latin typeface="Arial"/>
               </a:rPr>
-              <a:t>AZERION SPEND</a:t>
+              <a:t>SPEND</a:t>
             </a:r>
           </a:p>
         </p:txBody>
@@ -9443,7 +9443,7 @@
         <p:spPr>
           <a:xfrm>
             <a:off x="640080" y="2029967"/>
-            <a:ext cx="1920240" cy="457200"/>
+            <a:ext cx="1463039" cy="457200"/>
           </a:xfrm>
           <a:prstGeom prst="rect">
             <a:avLst/>
@@ -9478,7 +9478,7 @@
         <p:spPr>
           <a:xfrm>
             <a:off x="640080" y="2487168"/>
-            <a:ext cx="1920240" cy="219456"/>
+            <a:ext cx="1463039" cy="219456"/>
           </a:xfrm>
           <a:prstGeom prst="rect">
             <a:avLst/>
@@ -9512,8 +9512,8 @@
         </p:nvSpPr>
         <p:spPr>
           <a:xfrm>
-            <a:off x="2743200" y="1737360"/>
-            <a:ext cx="2194560" cy="1005840"/>
+            <a:off x="2286000" y="1737360"/>
+            <a:ext cx="1737360" cy="1005840"/>
           </a:xfrm>
           <a:prstGeom prst="rect">
             <a:avLst/>
@@ -9556,7 +9556,7 @@
         </p:nvSpPr>
         <p:spPr>
           <a:xfrm>
-            <a:off x="2743200" y="1737360"/>
+            <a:off x="2286000" y="1737360"/>
             <a:ext cx="91440" cy="1005840"/>
           </a:xfrm>
           <a:prstGeom prst="rect">
@@ -9600,8 +9600,8 @@
         </p:nvSpPr>
         <p:spPr>
           <a:xfrm>
-            <a:off x="2926080" y="1783080"/>
-            <a:ext cx="1920240" cy="274320"/>
+            <a:off x="2468880" y="1783080"/>
+            <a:ext cx="1463039" cy="274320"/>
           </a:xfrm>
           <a:prstGeom prst="rect">
             <a:avLst/>
@@ -9622,7 +9622,7 @@
                 </a:solidFill>
                 <a:latin typeface="Arial"/>
               </a:rPr>
-              <a:t>MAY BASELINE</a:t>
+              <a:t>IMPRESSIONS</a:t>
             </a:r>
           </a:p>
         </p:txBody>
@@ -9635,8 +9635,8 @@
         </p:nvSpPr>
         <p:spPr>
           <a:xfrm>
-            <a:off x="2926080" y="2029967"/>
-            <a:ext cx="1920240" cy="457200"/>
+            <a:off x="2468880" y="2029967"/>
+            <a:ext cx="1463039" cy="457200"/>
           </a:xfrm>
           <a:prstGeom prst="rect">
             <a:avLst/>
@@ -9657,7 +9657,7 @@
                 </a:solidFill>
                 <a:latin typeface="Arial"/>
               </a:rPr>
-              <a:t>43 apps</a:t>
+              <a:t>4.52M</a:t>
             </a:r>
           </a:p>
         </p:txBody>
@@ -9670,8 +9670,8 @@
         </p:nvSpPr>
         <p:spPr>
           <a:xfrm>
-            <a:off x="2926080" y="2487168"/>
-            <a:ext cx="1920240" cy="219456"/>
+            <a:off x="2468880" y="2487168"/>
+            <a:ext cx="1463039" cy="219456"/>
           </a:xfrm>
           <a:prstGeom prst="rect">
             <a:avLst/>
@@ -9692,7 +9692,7 @@
                 </a:solidFill>
                 <a:latin typeface="Arial"/>
               </a:rPr>
-              <a:t>$616 CPA</a:t>
+              <a:t>CPM $6.55</a:t>
             </a:r>
           </a:p>
         </p:txBody>
@@ -9705,8 +9705,8 @@
         </p:nvSpPr>
         <p:spPr>
           <a:xfrm>
-            <a:off x="5029200" y="1737360"/>
-            <a:ext cx="2194560" cy="1005840"/>
+            <a:off x="4114800" y="1737360"/>
+            <a:ext cx="1737360" cy="1005840"/>
           </a:xfrm>
           <a:prstGeom prst="rect">
             <a:avLst/>
@@ -9749,7 +9749,7 @@
         </p:nvSpPr>
         <p:spPr>
           <a:xfrm>
-            <a:off x="5029200" y="1737360"/>
+            <a:off x="4114800" y="1737360"/>
             <a:ext cx="91440" cy="1005840"/>
           </a:xfrm>
           <a:prstGeom prst="rect">
@@ -9793,8 +9793,8 @@
         </p:nvSpPr>
         <p:spPr>
           <a:xfrm>
-            <a:off x="5212080" y="1783080"/>
-            <a:ext cx="1920240" cy="274320"/>
+            <a:off x="4297680" y="1783080"/>
+            <a:ext cx="1463039" cy="274320"/>
           </a:xfrm>
           <a:prstGeom prst="rect">
             <a:avLst/>
@@ -9815,7 +9815,7 @@
                 </a:solidFill>
                 <a:latin typeface="Arial"/>
               </a:rPr>
-              <a:t>NATIVE SPEND</a:t>
+              <a:t>CLICKS</a:t>
             </a:r>
           </a:p>
         </p:txBody>
@@ -9828,8 +9828,8 @@
         </p:nvSpPr>
         <p:spPr>
           <a:xfrm>
-            <a:off x="5212080" y="2029967"/>
-            <a:ext cx="1920240" cy="457200"/>
+            <a:off x="4297680" y="2029967"/>
+            <a:ext cx="1463039" cy="457200"/>
           </a:xfrm>
           <a:prstGeom prst="rect">
             <a:avLst/>
@@ -9850,7 +9850,7 @@
                 </a:solidFill>
                 <a:latin typeface="Arial"/>
               </a:rPr>
-              <a:t>$3,645</a:t>
+              <a:t>19,653</a:t>
             </a:r>
           </a:p>
         </p:txBody>
@@ -9863,8 +9863,8 @@
         </p:nvSpPr>
         <p:spPr>
           <a:xfrm>
-            <a:off x="5212080" y="2487168"/>
-            <a:ext cx="1920240" cy="219456"/>
+            <a:off x="4297680" y="2487168"/>
+            <a:ext cx="1463039" cy="219456"/>
           </a:xfrm>
           <a:prstGeom prst="rect">
             <a:avLst/>
@@ -9885,7 +9885,7 @@
                 </a:solidFill>
                 <a:latin typeface="Arial"/>
               </a:rPr>
-              <a:t>pilot month 1</a:t>
+              <a:t>CTR 0.44%</a:t>
             </a:r>
           </a:p>
         </p:txBody>
@@ -9898,8 +9898,8 @@
         </p:nvSpPr>
         <p:spPr>
           <a:xfrm>
-            <a:off x="457200" y="3063240"/>
-            <a:ext cx="5577840" cy="3246120"/>
+            <a:off x="5943600" y="1737360"/>
+            <a:ext cx="1737360" cy="1005840"/>
           </a:xfrm>
           <a:prstGeom prst="rect">
             <a:avLst/>
@@ -9942,8 +9942,8 @@
         </p:nvSpPr>
         <p:spPr>
           <a:xfrm>
-            <a:off x="457200" y="3063240"/>
-            <a:ext cx="5577840" cy="91440"/>
+            <a:off x="5943600" y="1737360"/>
+            <a:ext cx="91440" cy="1005840"/>
           </a:xfrm>
           <a:prstGeom prst="rect">
             <a:avLst/>
@@ -9986,8 +9986,8 @@
         </p:nvSpPr>
         <p:spPr>
           <a:xfrm>
-            <a:off x="640080" y="3246120"/>
-            <a:ext cx="5212079" cy="274320"/>
+            <a:off x="6126480" y="1783080"/>
+            <a:ext cx="1463039" cy="274320"/>
           </a:xfrm>
           <a:prstGeom prst="rect">
             <a:avLst/>
@@ -10002,13 +10002,13 @@
           <a:p>
             <a:pPr algn="l"/>
             <a:r>
-              <a:rPr sz="1000" b="1">
-                <a:solidFill>
-                  <a:srgbClr val="3B5998"/>
+              <a:rPr sz="800" b="1">
+                <a:solidFill>
+                  <a:srgbClr val="78828C"/>
                 </a:solidFill>
                 <a:latin typeface="Arial"/>
               </a:rPr>
-              <a:t>WHAT WE KNOW</a:t>
+              <a:t>APP STARTS</a:t>
             </a:r>
           </a:p>
         </p:txBody>
@@ -10021,8 +10021,8 @@
         </p:nvSpPr>
         <p:spPr>
           <a:xfrm>
-            <a:off x="640080" y="3566160"/>
-            <a:ext cx="5212079" cy="2560320"/>
+            <a:off x="6126480" y="2029967"/>
+            <a:ext cx="1463039" cy="457200"/>
           </a:xfrm>
           <a:prstGeom prst="rect">
             <a:avLst/>
@@ -10037,43 +10037,62 @@
           <a:p>
             <a:pPr algn="l"/>
             <a:r>
-              <a:rPr sz="950" b="0">
-                <a:solidFill>
-                  <a:srgbClr val="32373E"/>
+              <a:rPr sz="1500" b="1">
+                <a:solidFill>
+                  <a:srgbClr val="1A2A3A"/>
                 </a:solidFill>
                 <a:latin typeface="Arial"/>
               </a:rPr>
-              <a:t>Azerion grew 12% to $29,586 per the budget tracker. It has been GCG's largest converter (76 applications in April, 43 in May with 1,398 starts), and its June application detail arrives with the vendor file.</a:t>
-            </a:r>
-          </a:p>
-          <a:p>
-            <a:pPr algn="l">
-              <a:spcBef>
-                <a:spcPts val="600"/>
-              </a:spcBef>
-            </a:pPr>
-            <a:r>
-              <a:rPr sz="950" b="0">
-                <a:solidFill>
-                  <a:srgbClr val="32373E"/>
+              <a:t>447</a:t>
+            </a:r>
+          </a:p>
+        </p:txBody>
+      </p:sp>
+      <p:sp>
+        <p:nvSpPr>
+          <p:cNvPr id="29" name="TextBox 28"/>
+          <p:cNvSpPr txBox="1"/>
+          <p:nvPr/>
+        </p:nvSpPr>
+        <p:spPr>
+          <a:xfrm>
+            <a:off x="6126480" y="2487168"/>
+            <a:ext cx="1463039" cy="219456"/>
+          </a:xfrm>
+          <a:prstGeom prst="rect">
+            <a:avLst/>
+          </a:prstGeom>
+          <a:noFill/>
+        </p:spPr>
+        <p:txBody>
+          <a:bodyPr wrap="square" anchor="t" lIns="0" rIns="0" tIns="0" bIns="0">
+            <a:spAutoFit/>
+          </a:bodyPr>
+          <a:lstStyle/>
+          <a:p>
+            <a:pPr algn="l"/>
+            <a:r>
+              <a:rPr sz="800" b="0">
+                <a:solidFill>
+                  <a:srgbClr val="5A5A5A"/>
                 </a:solidFill>
                 <a:latin typeface="Arial"/>
               </a:rPr>
-              <a:t>Native entered the market with $3,645 in June, the first new channel since the program launched.</a:t>
-            </a:r>
-          </a:p>
-        </p:txBody>
-      </p:sp>
-      <p:sp>
-        <p:nvSpPr>
-          <p:cNvPr id="29" name="Rectangle 28"/>
+              <a:t>May: 1,398</a:t>
+            </a:r>
+          </a:p>
+        </p:txBody>
+      </p:sp>
+      <p:sp>
+        <p:nvSpPr>
+          <p:cNvPr id="30" name="Rectangle 29"/>
           <p:cNvSpPr/>
           <p:nvPr/>
         </p:nvSpPr>
         <p:spPr>
           <a:xfrm>
-            <a:off x="6309360" y="3063240"/>
-            <a:ext cx="5394960" cy="3246120"/>
+            <a:off x="7772400" y="1737360"/>
+            <a:ext cx="1737360" cy="1005840"/>
           </a:xfrm>
           <a:prstGeom prst="rect">
             <a:avLst/>
@@ -10110,14 +10129,1114 @@
       </p:sp>
       <p:sp>
         <p:nvSpPr>
-          <p:cNvPr id="30" name="Rectangle 29"/>
+          <p:cNvPr id="31" name="Rectangle 30"/>
           <p:cNvSpPr/>
           <p:nvPr/>
         </p:nvSpPr>
         <p:spPr>
           <a:xfrm>
-            <a:off x="6309360" y="3063240"/>
-            <a:ext cx="5394960" cy="91440"/>
+            <a:off x="7772400" y="1737360"/>
+            <a:ext cx="91440" cy="1005840"/>
+          </a:xfrm>
+          <a:prstGeom prst="rect">
+            <a:avLst/>
+          </a:prstGeom>
+          <a:solidFill>
+            <a:srgbClr val="3B5998"/>
+          </a:solidFill>
+          <a:ln>
+            <a:noFill/>
+          </a:ln>
+          <a:effectLst/>
+        </p:spPr>
+        <p:style>
+          <a:lnRef idx="1">
+            <a:schemeClr val="accent1"/>
+          </a:lnRef>
+          <a:fillRef idx="3">
+            <a:schemeClr val="accent1"/>
+          </a:fillRef>
+          <a:effectRef idx="2">
+            <a:schemeClr val="accent1"/>
+          </a:effectRef>
+          <a:fontRef idx="minor">
+            <a:schemeClr val="lt1"/>
+          </a:fontRef>
+        </p:style>
+        <p:txBody>
+          <a:bodyPr rtlCol="0" anchor="ctr"/>
+          <a:lstStyle/>
+          <a:p>
+            <a:pPr algn="ctr"/>
+          </a:p>
+        </p:txBody>
+      </p:sp>
+      <p:sp>
+        <p:nvSpPr>
+          <p:cNvPr id="32" name="TextBox 31"/>
+          <p:cNvSpPr txBox="1"/>
+          <p:nvPr/>
+        </p:nvSpPr>
+        <p:spPr>
+          <a:xfrm>
+            <a:off x="7955279" y="1783080"/>
+            <a:ext cx="1463039" cy="274320"/>
+          </a:xfrm>
+          <a:prstGeom prst="rect">
+            <a:avLst/>
+          </a:prstGeom>
+          <a:noFill/>
+        </p:spPr>
+        <p:txBody>
+          <a:bodyPr wrap="square" anchor="t" lIns="0" rIns="0" tIns="0" bIns="0">
+            <a:spAutoFit/>
+          </a:bodyPr>
+          <a:lstStyle/>
+          <a:p>
+            <a:pPr algn="l"/>
+            <a:r>
+              <a:rPr sz="800" b="1">
+                <a:solidFill>
+                  <a:srgbClr val="78828C"/>
+                </a:solidFill>
+                <a:latin typeface="Arial"/>
+              </a:rPr>
+              <a:t>APPLICATIONS</a:t>
+            </a:r>
+          </a:p>
+        </p:txBody>
+      </p:sp>
+      <p:sp>
+        <p:nvSpPr>
+          <p:cNvPr id="33" name="TextBox 32"/>
+          <p:cNvSpPr txBox="1"/>
+          <p:nvPr/>
+        </p:nvSpPr>
+        <p:spPr>
+          <a:xfrm>
+            <a:off x="7955279" y="2029967"/>
+            <a:ext cx="1463039" cy="457200"/>
+          </a:xfrm>
+          <a:prstGeom prst="rect">
+            <a:avLst/>
+          </a:prstGeom>
+          <a:noFill/>
+        </p:spPr>
+        <p:txBody>
+          <a:bodyPr wrap="square" anchor="t" lIns="0" rIns="0" tIns="0" bIns="0">
+            <a:spAutoFit/>
+          </a:bodyPr>
+          <a:lstStyle/>
+          <a:p>
+            <a:pPr algn="l"/>
+            <a:r>
+              <a:rPr sz="1500" b="1">
+                <a:solidFill>
+                  <a:srgbClr val="1A2A3A"/>
+                </a:solidFill>
+                <a:latin typeface="Arial"/>
+              </a:rPr>
+              <a:t>58</a:t>
+            </a:r>
+          </a:p>
+        </p:txBody>
+      </p:sp>
+      <p:sp>
+        <p:nvSpPr>
+          <p:cNvPr id="34" name="TextBox 33"/>
+          <p:cNvSpPr txBox="1"/>
+          <p:nvPr/>
+        </p:nvSpPr>
+        <p:spPr>
+          <a:xfrm>
+            <a:off x="7955279" y="2487168"/>
+            <a:ext cx="1463039" cy="219456"/>
+          </a:xfrm>
+          <a:prstGeom prst="rect">
+            <a:avLst/>
+          </a:prstGeom>
+          <a:noFill/>
+        </p:spPr>
+        <p:txBody>
+          <a:bodyPr wrap="square" anchor="t" lIns="0" rIns="0" tIns="0" bIns="0">
+            <a:spAutoFit/>
+          </a:bodyPr>
+          <a:lstStyle/>
+          <a:p>
+            <a:pPr algn="l"/>
+            <a:r>
+              <a:rPr sz="800" b="0">
+                <a:solidFill>
+                  <a:srgbClr val="5A5A5A"/>
+                </a:solidFill>
+                <a:latin typeface="Arial"/>
+              </a:rPr>
+              <a:t>$510 CPA</a:t>
+            </a:r>
+          </a:p>
+        </p:txBody>
+      </p:sp>
+      <p:sp>
+        <p:nvSpPr>
+          <p:cNvPr id="35" name="Rectangle 34"/>
+          <p:cNvSpPr/>
+          <p:nvPr/>
+        </p:nvSpPr>
+        <p:spPr>
+          <a:xfrm>
+            <a:off x="9601200" y="1737360"/>
+            <a:ext cx="1737360" cy="1005840"/>
+          </a:xfrm>
+          <a:prstGeom prst="rect">
+            <a:avLst/>
+          </a:prstGeom>
+          <a:solidFill>
+            <a:srgbClr val="F3F3F3"/>
+          </a:solidFill>
+          <a:ln>
+            <a:noFill/>
+          </a:ln>
+          <a:effectLst/>
+        </p:spPr>
+        <p:style>
+          <a:lnRef idx="1">
+            <a:schemeClr val="accent1"/>
+          </a:lnRef>
+          <a:fillRef idx="3">
+            <a:schemeClr val="accent1"/>
+          </a:fillRef>
+          <a:effectRef idx="2">
+            <a:schemeClr val="accent1"/>
+          </a:effectRef>
+          <a:fontRef idx="minor">
+            <a:schemeClr val="lt1"/>
+          </a:fontRef>
+        </p:style>
+        <p:txBody>
+          <a:bodyPr rtlCol="0" anchor="ctr"/>
+          <a:lstStyle/>
+          <a:p>
+            <a:pPr algn="ctr"/>
+          </a:p>
+        </p:txBody>
+      </p:sp>
+      <p:sp>
+        <p:nvSpPr>
+          <p:cNvPr id="36" name="Rectangle 35"/>
+          <p:cNvSpPr/>
+          <p:nvPr/>
+        </p:nvSpPr>
+        <p:spPr>
+          <a:xfrm>
+            <a:off x="9601200" y="1737360"/>
+            <a:ext cx="91440" cy="1005840"/>
+          </a:xfrm>
+          <a:prstGeom prst="rect">
+            <a:avLst/>
+          </a:prstGeom>
+          <a:solidFill>
+            <a:srgbClr val="3B5998"/>
+          </a:solidFill>
+          <a:ln>
+            <a:noFill/>
+          </a:ln>
+          <a:effectLst/>
+        </p:spPr>
+        <p:style>
+          <a:lnRef idx="1">
+            <a:schemeClr val="accent1"/>
+          </a:lnRef>
+          <a:fillRef idx="3">
+            <a:schemeClr val="accent1"/>
+          </a:fillRef>
+          <a:effectRef idx="2">
+            <a:schemeClr val="accent1"/>
+          </a:effectRef>
+          <a:fontRef idx="minor">
+            <a:schemeClr val="lt1"/>
+          </a:fontRef>
+        </p:style>
+        <p:txBody>
+          <a:bodyPr rtlCol="0" anchor="ctr"/>
+          <a:lstStyle/>
+          <a:p>
+            <a:pPr algn="ctr"/>
+          </a:p>
+        </p:txBody>
+      </p:sp>
+      <p:sp>
+        <p:nvSpPr>
+          <p:cNvPr id="37" name="TextBox 36"/>
+          <p:cNvSpPr txBox="1"/>
+          <p:nvPr/>
+        </p:nvSpPr>
+        <p:spPr>
+          <a:xfrm>
+            <a:off x="9784080" y="1783080"/>
+            <a:ext cx="1463039" cy="274320"/>
+          </a:xfrm>
+          <a:prstGeom prst="rect">
+            <a:avLst/>
+          </a:prstGeom>
+          <a:noFill/>
+        </p:spPr>
+        <p:txBody>
+          <a:bodyPr wrap="square" anchor="t" lIns="0" rIns="0" tIns="0" bIns="0">
+            <a:spAutoFit/>
+          </a:bodyPr>
+          <a:lstStyle/>
+          <a:p>
+            <a:pPr algn="l"/>
+            <a:r>
+              <a:rPr sz="800" b="1">
+                <a:solidFill>
+                  <a:srgbClr val="78828C"/>
+                </a:solidFill>
+                <a:latin typeface="Arial"/>
+              </a:rPr>
+              <a:t>VIEWABILITY</a:t>
+            </a:r>
+          </a:p>
+        </p:txBody>
+      </p:sp>
+      <p:sp>
+        <p:nvSpPr>
+          <p:cNvPr id="38" name="TextBox 37"/>
+          <p:cNvSpPr txBox="1"/>
+          <p:nvPr/>
+        </p:nvSpPr>
+        <p:spPr>
+          <a:xfrm>
+            <a:off x="9784080" y="2029967"/>
+            <a:ext cx="1463039" cy="457200"/>
+          </a:xfrm>
+          <a:prstGeom prst="rect">
+            <a:avLst/>
+          </a:prstGeom>
+          <a:noFill/>
+        </p:spPr>
+        <p:txBody>
+          <a:bodyPr wrap="square" anchor="t" lIns="0" rIns="0" tIns="0" bIns="0">
+            <a:spAutoFit/>
+          </a:bodyPr>
+          <a:lstStyle/>
+          <a:p>
+            <a:pPr algn="l"/>
+            <a:r>
+              <a:rPr sz="1500" b="1">
+                <a:solidFill>
+                  <a:srgbClr val="1A2A3A"/>
+                </a:solidFill>
+                <a:latin typeface="Arial"/>
+              </a:rPr>
+              <a:t>58.8%</a:t>
+            </a:r>
+          </a:p>
+        </p:txBody>
+      </p:sp>
+      <p:sp>
+        <p:nvSpPr>
+          <p:cNvPr id="39" name="TextBox 38"/>
+          <p:cNvSpPr txBox="1"/>
+          <p:nvPr/>
+        </p:nvSpPr>
+        <p:spPr>
+          <a:xfrm>
+            <a:off x="9784080" y="2487168"/>
+            <a:ext cx="1463039" cy="219456"/>
+          </a:xfrm>
+          <a:prstGeom prst="rect">
+            <a:avLst/>
+          </a:prstGeom>
+          <a:noFill/>
+        </p:spPr>
+        <p:txBody>
+          <a:bodyPr wrap="square" anchor="t" lIns="0" rIns="0" tIns="0" bIns="0">
+            <a:spAutoFit/>
+          </a:bodyPr>
+          <a:lstStyle/>
+          <a:p>
+            <a:pPr algn="l"/>
+            <a:r>
+              <a:rPr sz="800" b="0">
+                <a:solidFill>
+                  <a:srgbClr val="5A5A5A"/>
+                </a:solidFill>
+                <a:latin typeface="Arial"/>
+              </a:rPr>
+              <a:t>70% standard</a:t>
+            </a:r>
+          </a:p>
+        </p:txBody>
+      </p:sp>
+      <p:sp>
+        <p:nvSpPr>
+          <p:cNvPr id="40" name="TextBox 39"/>
+          <p:cNvSpPr txBox="1"/>
+          <p:nvPr/>
+        </p:nvSpPr>
+        <p:spPr>
+          <a:xfrm>
+            <a:off x="457200" y="3063240"/>
+            <a:ext cx="5486400" cy="274320"/>
+          </a:xfrm>
+          <a:prstGeom prst="rect">
+            <a:avLst/>
+          </a:prstGeom>
+          <a:noFill/>
+        </p:spPr>
+        <p:txBody>
+          <a:bodyPr wrap="square" anchor="t" lIns="0" rIns="0" tIns="0" bIns="0">
+            <a:spAutoFit/>
+          </a:bodyPr>
+          <a:lstStyle/>
+          <a:p>
+            <a:pPr algn="l"/>
+            <a:r>
+              <a:rPr sz="1100" b="1">
+                <a:solidFill>
+                  <a:srgbClr val="1A2A3A"/>
+                </a:solidFill>
+                <a:latin typeface="Arial"/>
+              </a:rPr>
+              <a:t>Ad Sets (Applications)</a:t>
+            </a:r>
+          </a:p>
+        </p:txBody>
+      </p:sp>
+      <p:graphicFrame>
+        <p:nvGraphicFramePr>
+          <p:cNvPr id="41" name="Table 40"/>
+          <p:cNvGraphicFramePr>
+            <a:graphicFrameLocks noGrp="1"/>
+          </p:cNvGraphicFramePr>
+          <p:nvPr/>
+        </p:nvGraphicFramePr>
+        <p:xfrm>
+          <a:off x="457200" y="3337560"/>
+          <a:ext cx="5303520" cy="2103120"/>
+        </p:xfrm>
+        <a:graphic>
+          <a:graphicData uri="http://schemas.openxmlformats.org/drawingml/2006/table">
+            <a:tbl>
+              <a:tblPr>
+                <a:tableStyleId>{5C22544A-7EE6-4342-B048-85BDC9FD1C3A}</a:tableStyleId>
+              </a:tblPr>
+              <a:tblGrid>
+                <a:gridCol w="2377440"/>
+                <a:gridCol w="1005840"/>
+                <a:gridCol w="822960"/>
+                <a:gridCol w="1097280"/>
+              </a:tblGrid>
+              <a:tr h="300445">
+                <a:tc>
+                  <a:txBody>
+                    <a:bodyPr/>
+                    <a:lstStyle/>
+                    <a:p>
+                      <a:r>
+                        <a:rPr sz="850" b="1">
+                          <a:solidFill>
+                            <a:srgbClr val="FFFFFF"/>
+                          </a:solidFill>
+                          <a:latin typeface="Arial"/>
+                        </a:rPr>
+                        <a:t>Ad Set</a:t>
+                      </a:r>
+                    </a:p>
+                  </a:txBody>
+                  <a:tcPr marL="54864" marR="54864" marT="27432" marB="27432">
+                    <a:solidFill>
+                      <a:srgbClr val="3B5998"/>
+                    </a:solidFill>
+                  </a:tcPr>
+                </a:tc>
+                <a:tc>
+                  <a:txBody>
+                    <a:bodyPr/>
+                    <a:lstStyle/>
+                    <a:p>
+                      <a:pPr algn="r"/>
+                      <a:r>
+                        <a:rPr sz="850" b="1">
+                          <a:solidFill>
+                            <a:srgbClr val="FFFFFF"/>
+                          </a:solidFill>
+                          <a:latin typeface="Arial"/>
+                        </a:rPr>
+                        <a:t>Spend</a:t>
+                      </a:r>
+                    </a:p>
+                  </a:txBody>
+                  <a:tcPr marL="54864" marR="54864" marT="27432" marB="27432">
+                    <a:solidFill>
+                      <a:srgbClr val="3B5998"/>
+                    </a:solidFill>
+                  </a:tcPr>
+                </a:tc>
+                <a:tc>
+                  <a:txBody>
+                    <a:bodyPr/>
+                    <a:lstStyle/>
+                    <a:p>
+                      <a:pPr algn="r"/>
+                      <a:r>
+                        <a:rPr sz="850" b="1">
+                          <a:solidFill>
+                            <a:srgbClr val="FFFFFF"/>
+                          </a:solidFill>
+                          <a:latin typeface="Arial"/>
+                        </a:rPr>
+                        <a:t>Apps</a:t>
+                      </a:r>
+                    </a:p>
+                  </a:txBody>
+                  <a:tcPr marL="54864" marR="54864" marT="27432" marB="27432">
+                    <a:solidFill>
+                      <a:srgbClr val="3B5998"/>
+                    </a:solidFill>
+                  </a:tcPr>
+                </a:tc>
+                <a:tc>
+                  <a:txBody>
+                    <a:bodyPr/>
+                    <a:lstStyle/>
+                    <a:p>
+                      <a:pPr algn="r"/>
+                      <a:r>
+                        <a:rPr sz="850" b="1">
+                          <a:solidFill>
+                            <a:srgbClr val="FFFFFF"/>
+                          </a:solidFill>
+                          <a:latin typeface="Arial"/>
+                        </a:rPr>
+                        <a:t>CPA</a:t>
+                      </a:r>
+                    </a:p>
+                  </a:txBody>
+                  <a:tcPr marL="54864" marR="54864" marT="27432" marB="27432">
+                    <a:solidFill>
+                      <a:srgbClr val="3B5998"/>
+                    </a:solidFill>
+                  </a:tcPr>
+                </a:tc>
+              </a:tr>
+              <a:tr h="300445">
+                <a:tc>
+                  <a:txBody>
+                    <a:bodyPr/>
+                    <a:lstStyle/>
+                    <a:p>
+                      <a:r>
+                        <a:rPr sz="850" b="1">
+                          <a:solidFill>
+                            <a:srgbClr val="32373E"/>
+                          </a:solidFill>
+                          <a:latin typeface="Arial"/>
+                        </a:rPr>
+                        <a:t>Trusted Broker</a:t>
+                      </a:r>
+                    </a:p>
+                  </a:txBody>
+                  <a:tcPr marL="54864" marR="54864" marT="27432" marB="27432">
+                    <a:solidFill>
+                      <a:srgbClr val="FFFFFF"/>
+                    </a:solidFill>
+                  </a:tcPr>
+                </a:tc>
+                <a:tc>
+                  <a:txBody>
+                    <a:bodyPr/>
+                    <a:lstStyle/>
+                    <a:p>
+                      <a:pPr algn="r"/>
+                      <a:r>
+                        <a:rPr sz="850" b="0">
+                          <a:solidFill>
+                            <a:srgbClr val="32373E"/>
+                          </a:solidFill>
+                          <a:latin typeface="Arial"/>
+                        </a:rPr>
+                        <a:t>$4,933</a:t>
+                      </a:r>
+                    </a:p>
+                  </a:txBody>
+                  <a:tcPr marL="54864" marR="54864" marT="27432" marB="27432">
+                    <a:solidFill>
+                      <a:srgbClr val="FFFFFF"/>
+                    </a:solidFill>
+                  </a:tcPr>
+                </a:tc>
+                <a:tc>
+                  <a:txBody>
+                    <a:bodyPr/>
+                    <a:lstStyle/>
+                    <a:p>
+                      <a:pPr algn="r"/>
+                      <a:r>
+                        <a:rPr sz="850" b="0">
+                          <a:solidFill>
+                            <a:srgbClr val="32373E"/>
+                          </a:solidFill>
+                          <a:latin typeface="Arial"/>
+                        </a:rPr>
+                        <a:t>14</a:t>
+                      </a:r>
+                    </a:p>
+                  </a:txBody>
+                  <a:tcPr marL="54864" marR="54864" marT="27432" marB="27432">
+                    <a:solidFill>
+                      <a:srgbClr val="FFFFFF"/>
+                    </a:solidFill>
+                  </a:tcPr>
+                </a:tc>
+                <a:tc>
+                  <a:txBody>
+                    <a:bodyPr/>
+                    <a:lstStyle/>
+                    <a:p>
+                      <a:pPr algn="r"/>
+                      <a:r>
+                        <a:rPr sz="850" b="0">
+                          <a:solidFill>
+                            <a:srgbClr val="32373E"/>
+                          </a:solidFill>
+                          <a:latin typeface="Arial"/>
+                        </a:rPr>
+                        <a:t>$352</a:t>
+                      </a:r>
+                    </a:p>
+                  </a:txBody>
+                  <a:tcPr marL="54864" marR="54864" marT="27432" marB="27432">
+                    <a:solidFill>
+                      <a:srgbClr val="FFFFFF"/>
+                    </a:solidFill>
+                  </a:tcPr>
+                </a:tc>
+              </a:tr>
+              <a:tr h="300445">
+                <a:tc>
+                  <a:txBody>
+                    <a:bodyPr/>
+                    <a:lstStyle/>
+                    <a:p>
+                      <a:r>
+                        <a:rPr sz="850" b="1">
+                          <a:solidFill>
+                            <a:srgbClr val="32373E"/>
+                          </a:solidFill>
+                          <a:latin typeface="Arial"/>
+                        </a:rPr>
+                        <a:t>Broker 1</a:t>
+                      </a:r>
+                    </a:p>
+                  </a:txBody>
+                  <a:tcPr marL="54864" marR="54864" marT="27432" marB="27432">
+                    <a:solidFill>
+                      <a:srgbClr val="F3F3F3"/>
+                    </a:solidFill>
+                  </a:tcPr>
+                </a:tc>
+                <a:tc>
+                  <a:txBody>
+                    <a:bodyPr/>
+                    <a:lstStyle/>
+                    <a:p>
+                      <a:pPr algn="r"/>
+                      <a:r>
+                        <a:rPr sz="850" b="0">
+                          <a:solidFill>
+                            <a:srgbClr val="32373E"/>
+                          </a:solidFill>
+                          <a:latin typeface="Arial"/>
+                        </a:rPr>
+                        <a:t>$4,964</a:t>
+                      </a:r>
+                    </a:p>
+                  </a:txBody>
+                  <a:tcPr marL="54864" marR="54864" marT="27432" marB="27432">
+                    <a:solidFill>
+                      <a:srgbClr val="F3F3F3"/>
+                    </a:solidFill>
+                  </a:tcPr>
+                </a:tc>
+                <a:tc>
+                  <a:txBody>
+                    <a:bodyPr/>
+                    <a:lstStyle/>
+                    <a:p>
+                      <a:pPr algn="r"/>
+                      <a:r>
+                        <a:rPr sz="850" b="0">
+                          <a:solidFill>
+                            <a:srgbClr val="32373E"/>
+                          </a:solidFill>
+                          <a:latin typeface="Arial"/>
+                        </a:rPr>
+                        <a:t>13</a:t>
+                      </a:r>
+                    </a:p>
+                  </a:txBody>
+                  <a:tcPr marL="54864" marR="54864" marT="27432" marB="27432">
+                    <a:solidFill>
+                      <a:srgbClr val="F3F3F3"/>
+                    </a:solidFill>
+                  </a:tcPr>
+                </a:tc>
+                <a:tc>
+                  <a:txBody>
+                    <a:bodyPr/>
+                    <a:lstStyle/>
+                    <a:p>
+                      <a:pPr algn="r"/>
+                      <a:r>
+                        <a:rPr sz="850" b="0">
+                          <a:solidFill>
+                            <a:srgbClr val="32373E"/>
+                          </a:solidFill>
+                          <a:latin typeface="Arial"/>
+                        </a:rPr>
+                        <a:t>$382</a:t>
+                      </a:r>
+                    </a:p>
+                  </a:txBody>
+                  <a:tcPr marL="54864" marR="54864" marT="27432" marB="27432">
+                    <a:solidFill>
+                      <a:srgbClr val="F3F3F3"/>
+                    </a:solidFill>
+                  </a:tcPr>
+                </a:tc>
+              </a:tr>
+              <a:tr h="300445">
+                <a:tc>
+                  <a:txBody>
+                    <a:bodyPr/>
+                    <a:lstStyle/>
+                    <a:p>
+                      <a:r>
+                        <a:rPr sz="850" b="1">
+                          <a:solidFill>
+                            <a:srgbClr val="32373E"/>
+                          </a:solidFill>
+                          <a:latin typeface="Arial"/>
+                        </a:rPr>
+                        <a:t>Language Broker</a:t>
+                      </a:r>
+                    </a:p>
+                  </a:txBody>
+                  <a:tcPr marL="54864" marR="54864" marT="27432" marB="27432">
+                    <a:solidFill>
+                      <a:srgbClr val="FFFFFF"/>
+                    </a:solidFill>
+                  </a:tcPr>
+                </a:tc>
+                <a:tc>
+                  <a:txBody>
+                    <a:bodyPr/>
+                    <a:lstStyle/>
+                    <a:p>
+                      <a:pPr algn="r"/>
+                      <a:r>
+                        <a:rPr sz="850" b="0">
+                          <a:solidFill>
+                            <a:srgbClr val="32373E"/>
+                          </a:solidFill>
+                          <a:latin typeface="Arial"/>
+                        </a:rPr>
+                        <a:t>$4,900</a:t>
+                      </a:r>
+                    </a:p>
+                  </a:txBody>
+                  <a:tcPr marL="54864" marR="54864" marT="27432" marB="27432">
+                    <a:solidFill>
+                      <a:srgbClr val="FFFFFF"/>
+                    </a:solidFill>
+                  </a:tcPr>
+                </a:tc>
+                <a:tc>
+                  <a:txBody>
+                    <a:bodyPr/>
+                    <a:lstStyle/>
+                    <a:p>
+                      <a:pPr algn="r"/>
+                      <a:r>
+                        <a:rPr sz="850" b="0">
+                          <a:solidFill>
+                            <a:srgbClr val="32373E"/>
+                          </a:solidFill>
+                          <a:latin typeface="Arial"/>
+                        </a:rPr>
+                        <a:t>10</a:t>
+                      </a:r>
+                    </a:p>
+                  </a:txBody>
+                  <a:tcPr marL="54864" marR="54864" marT="27432" marB="27432">
+                    <a:solidFill>
+                      <a:srgbClr val="FFFFFF"/>
+                    </a:solidFill>
+                  </a:tcPr>
+                </a:tc>
+                <a:tc>
+                  <a:txBody>
+                    <a:bodyPr/>
+                    <a:lstStyle/>
+                    <a:p>
+                      <a:pPr algn="r"/>
+                      <a:r>
+                        <a:rPr sz="850" b="0">
+                          <a:solidFill>
+                            <a:srgbClr val="32373E"/>
+                          </a:solidFill>
+                          <a:latin typeface="Arial"/>
+                        </a:rPr>
+                        <a:t>$490</a:t>
+                      </a:r>
+                    </a:p>
+                  </a:txBody>
+                  <a:tcPr marL="54864" marR="54864" marT="27432" marB="27432">
+                    <a:solidFill>
+                      <a:srgbClr val="FFFFFF"/>
+                    </a:solidFill>
+                  </a:tcPr>
+                </a:tc>
+              </a:tr>
+              <a:tr h="300445">
+                <a:tc>
+                  <a:txBody>
+                    <a:bodyPr/>
+                    <a:lstStyle/>
+                    <a:p>
+                      <a:r>
+                        <a:rPr sz="850" b="1">
+                          <a:solidFill>
+                            <a:srgbClr val="32373E"/>
+                          </a:solidFill>
+                          <a:latin typeface="Arial"/>
+                        </a:rPr>
+                        <a:t>Professional Tools</a:t>
+                      </a:r>
+                    </a:p>
+                  </a:txBody>
+                  <a:tcPr marL="54864" marR="54864" marT="27432" marB="27432">
+                    <a:solidFill>
+                      <a:srgbClr val="F3F3F3"/>
+                    </a:solidFill>
+                  </a:tcPr>
+                </a:tc>
+                <a:tc>
+                  <a:txBody>
+                    <a:bodyPr/>
+                    <a:lstStyle/>
+                    <a:p>
+                      <a:pPr algn="r"/>
+                      <a:r>
+                        <a:rPr sz="850" b="0">
+                          <a:solidFill>
+                            <a:srgbClr val="32373E"/>
+                          </a:solidFill>
+                          <a:latin typeface="Arial"/>
+                        </a:rPr>
+                        <a:t>$4,940</a:t>
+                      </a:r>
+                    </a:p>
+                  </a:txBody>
+                  <a:tcPr marL="54864" marR="54864" marT="27432" marB="27432">
+                    <a:solidFill>
+                      <a:srgbClr val="F3F3F3"/>
+                    </a:solidFill>
+                  </a:tcPr>
+                </a:tc>
+                <a:tc>
+                  <a:txBody>
+                    <a:bodyPr/>
+                    <a:lstStyle/>
+                    <a:p>
+                      <a:pPr algn="r"/>
+                      <a:r>
+                        <a:rPr sz="850" b="0">
+                          <a:solidFill>
+                            <a:srgbClr val="32373E"/>
+                          </a:solidFill>
+                          <a:latin typeface="Arial"/>
+                        </a:rPr>
+                        <a:t>9</a:t>
+                      </a:r>
+                    </a:p>
+                  </a:txBody>
+                  <a:tcPr marL="54864" marR="54864" marT="27432" marB="27432">
+                    <a:solidFill>
+                      <a:srgbClr val="F3F3F3"/>
+                    </a:solidFill>
+                  </a:tcPr>
+                </a:tc>
+                <a:tc>
+                  <a:txBody>
+                    <a:bodyPr/>
+                    <a:lstStyle/>
+                    <a:p>
+                      <a:pPr algn="r"/>
+                      <a:r>
+                        <a:rPr sz="850" b="0">
+                          <a:solidFill>
+                            <a:srgbClr val="32373E"/>
+                          </a:solidFill>
+                          <a:latin typeface="Arial"/>
+                        </a:rPr>
+                        <a:t>$549</a:t>
+                      </a:r>
+                    </a:p>
+                  </a:txBody>
+                  <a:tcPr marL="54864" marR="54864" marT="27432" marB="27432">
+                    <a:solidFill>
+                      <a:srgbClr val="F3F3F3"/>
+                    </a:solidFill>
+                  </a:tcPr>
+                </a:tc>
+              </a:tr>
+              <a:tr h="300445">
+                <a:tc>
+                  <a:txBody>
+                    <a:bodyPr/>
+                    <a:lstStyle/>
+                    <a:p>
+                      <a:r>
+                        <a:rPr sz="850" b="1">
+                          <a:solidFill>
+                            <a:srgbClr val="32373E"/>
+                          </a:solidFill>
+                          <a:latin typeface="Arial"/>
+                        </a:rPr>
+                        <a:t>Spanish Platform</a:t>
+                      </a:r>
+                    </a:p>
+                  </a:txBody>
+                  <a:tcPr marL="54864" marR="54864" marT="27432" marB="27432">
+                    <a:solidFill>
+                      <a:srgbClr val="FFFFFF"/>
+                    </a:solidFill>
+                  </a:tcPr>
+                </a:tc>
+                <a:tc>
+                  <a:txBody>
+                    <a:bodyPr/>
+                    <a:lstStyle/>
+                    <a:p>
+                      <a:pPr algn="r"/>
+                      <a:r>
+                        <a:rPr sz="850" b="0">
+                          <a:solidFill>
+                            <a:srgbClr val="32373E"/>
+                          </a:solidFill>
+                          <a:latin typeface="Arial"/>
+                        </a:rPr>
+                        <a:t>$4,933</a:t>
+                      </a:r>
+                    </a:p>
+                  </a:txBody>
+                  <a:tcPr marL="54864" marR="54864" marT="27432" marB="27432">
+                    <a:solidFill>
+                      <a:srgbClr val="FFFFFF"/>
+                    </a:solidFill>
+                  </a:tcPr>
+                </a:tc>
+                <a:tc>
+                  <a:txBody>
+                    <a:bodyPr/>
+                    <a:lstStyle/>
+                    <a:p>
+                      <a:pPr algn="r"/>
+                      <a:r>
+                        <a:rPr sz="850" b="0">
+                          <a:solidFill>
+                            <a:srgbClr val="32373E"/>
+                          </a:solidFill>
+                          <a:latin typeface="Arial"/>
+                        </a:rPr>
+                        <a:t>7</a:t>
+                      </a:r>
+                    </a:p>
+                  </a:txBody>
+                  <a:tcPr marL="54864" marR="54864" marT="27432" marB="27432">
+                    <a:solidFill>
+                      <a:srgbClr val="FFFFFF"/>
+                    </a:solidFill>
+                  </a:tcPr>
+                </a:tc>
+                <a:tc>
+                  <a:txBody>
+                    <a:bodyPr/>
+                    <a:lstStyle/>
+                    <a:p>
+                      <a:pPr algn="r"/>
+                      <a:r>
+                        <a:rPr sz="850" b="0">
+                          <a:solidFill>
+                            <a:srgbClr val="32373E"/>
+                          </a:solidFill>
+                          <a:latin typeface="Arial"/>
+                        </a:rPr>
+                        <a:t>$705</a:t>
+                      </a:r>
+                    </a:p>
+                  </a:txBody>
+                  <a:tcPr marL="54864" marR="54864" marT="27432" marB="27432">
+                    <a:solidFill>
+                      <a:srgbClr val="FFFFFF"/>
+                    </a:solidFill>
+                  </a:tcPr>
+                </a:tc>
+              </a:tr>
+              <a:tr h="300450">
+                <a:tc>
+                  <a:txBody>
+                    <a:bodyPr/>
+                    <a:lstStyle/>
+                    <a:p>
+                      <a:r>
+                        <a:rPr sz="850" b="1">
+                          <a:solidFill>
+                            <a:srgbClr val="32373E"/>
+                          </a:solidFill>
+                          <a:latin typeface="Arial"/>
+                        </a:rPr>
+                        <a:t>Trust HTML</a:t>
+                      </a:r>
+                    </a:p>
+                  </a:txBody>
+                  <a:tcPr marL="54864" marR="54864" marT="27432" marB="27432">
+                    <a:solidFill>
+                      <a:srgbClr val="F3F3F3"/>
+                    </a:solidFill>
+                  </a:tcPr>
+                </a:tc>
+                <a:tc>
+                  <a:txBody>
+                    <a:bodyPr/>
+                    <a:lstStyle/>
+                    <a:p>
+                      <a:pPr algn="r"/>
+                      <a:r>
+                        <a:rPr sz="850" b="0">
+                          <a:solidFill>
+                            <a:srgbClr val="32373E"/>
+                          </a:solidFill>
+                          <a:latin typeface="Arial"/>
+                        </a:rPr>
+                        <a:t>$4,916</a:t>
+                      </a:r>
+                    </a:p>
+                  </a:txBody>
+                  <a:tcPr marL="54864" marR="54864" marT="27432" marB="27432">
+                    <a:solidFill>
+                      <a:srgbClr val="F3F3F3"/>
+                    </a:solidFill>
+                  </a:tcPr>
+                </a:tc>
+                <a:tc>
+                  <a:txBody>
+                    <a:bodyPr/>
+                    <a:lstStyle/>
+                    <a:p>
+                      <a:pPr algn="r"/>
+                      <a:r>
+                        <a:rPr sz="850" b="0">
+                          <a:solidFill>
+                            <a:srgbClr val="32373E"/>
+                          </a:solidFill>
+                          <a:latin typeface="Arial"/>
+                        </a:rPr>
+                        <a:t>5</a:t>
+                      </a:r>
+                    </a:p>
+                  </a:txBody>
+                  <a:tcPr marL="54864" marR="54864" marT="27432" marB="27432">
+                    <a:solidFill>
+                      <a:srgbClr val="F3F3F3"/>
+                    </a:solidFill>
+                  </a:tcPr>
+                </a:tc>
+                <a:tc>
+                  <a:txBody>
+                    <a:bodyPr/>
+                    <a:lstStyle/>
+                    <a:p>
+                      <a:pPr algn="r"/>
+                      <a:r>
+                        <a:rPr sz="850" b="0">
+                          <a:solidFill>
+                            <a:srgbClr val="32373E"/>
+                          </a:solidFill>
+                          <a:latin typeface="Arial"/>
+                        </a:rPr>
+                        <a:t>$983</a:t>
+                      </a:r>
+                    </a:p>
+                  </a:txBody>
+                  <a:tcPr marL="54864" marR="54864" marT="27432" marB="27432">
+                    <a:solidFill>
+                      <a:srgbClr val="F3F3F3"/>
+                    </a:solidFill>
+                  </a:tcPr>
+                </a:tc>
+              </a:tr>
+            </a:tbl>
+          </a:graphicData>
+        </a:graphic>
+      </p:graphicFrame>
+      <p:sp>
+        <p:nvSpPr>
+          <p:cNvPr id="42" name="Rectangle 41"/>
+          <p:cNvSpPr/>
+          <p:nvPr/>
+        </p:nvSpPr>
+        <p:spPr>
+          <a:xfrm>
+            <a:off x="6217920" y="3063240"/>
+            <a:ext cx="5486400" cy="2743200"/>
+          </a:xfrm>
+          <a:prstGeom prst="rect">
+            <a:avLst/>
+          </a:prstGeom>
+          <a:solidFill>
+            <a:srgbClr val="F3F3F3"/>
+          </a:solidFill>
+          <a:ln>
+            <a:noFill/>
+          </a:ln>
+          <a:effectLst/>
+        </p:spPr>
+        <p:style>
+          <a:lnRef idx="1">
+            <a:schemeClr val="accent1"/>
+          </a:lnRef>
+          <a:fillRef idx="3">
+            <a:schemeClr val="accent1"/>
+          </a:fillRef>
+          <a:effectRef idx="2">
+            <a:schemeClr val="accent1"/>
+          </a:effectRef>
+          <a:fontRef idx="minor">
+            <a:schemeClr val="lt1"/>
+          </a:fontRef>
+        </p:style>
+        <p:txBody>
+          <a:bodyPr rtlCol="0" anchor="ctr"/>
+          <a:lstStyle/>
+          <a:p>
+            <a:pPr algn="ctr"/>
+          </a:p>
+        </p:txBody>
+      </p:sp>
+      <p:sp>
+        <p:nvSpPr>
+          <p:cNvPr id="43" name="Rectangle 42"/>
+          <p:cNvSpPr/>
+          <p:nvPr/>
+        </p:nvSpPr>
+        <p:spPr>
+          <a:xfrm>
+            <a:off x="6217920" y="3063240"/>
+            <a:ext cx="5486400" cy="91440"/>
           </a:xfrm>
           <a:prstGeom prst="rect">
             <a:avLst/>
@@ -10154,14 +11273,14 @@
       </p:sp>
       <p:sp>
         <p:nvSpPr>
-          <p:cNvPr id="31" name="TextBox 30"/>
+          <p:cNvPr id="44" name="TextBox 43"/>
           <p:cNvSpPr txBox="1"/>
           <p:nvPr/>
         </p:nvSpPr>
         <p:spPr>
           <a:xfrm>
-            <a:off x="6492240" y="3246120"/>
-            <a:ext cx="5029200" cy="274320"/>
+            <a:off x="6400800" y="3246120"/>
+            <a:ext cx="5120640" cy="274320"/>
           </a:xfrm>
           <a:prstGeom prst="rect">
             <a:avLst/>
@@ -10182,21 +11301,21 @@
                 </a:solidFill>
                 <a:latin typeface="Arial"/>
               </a:rPr>
-              <a:t>WHAT COMES WITH THE VENDOR DETAIL</a:t>
-            </a:r>
-          </a:p>
-        </p:txBody>
-      </p:sp>
-      <p:sp>
-        <p:nvSpPr>
-          <p:cNvPr id="32" name="TextBox 31"/>
+              <a:t>READ</a:t>
+            </a:r>
+          </a:p>
+        </p:txBody>
+      </p:sp>
+      <p:sp>
+        <p:nvSpPr>
+          <p:cNvPr id="45" name="TextBox 44"/>
           <p:cNvSpPr txBox="1"/>
           <p:nvPr/>
         </p:nvSpPr>
         <p:spPr>
           <a:xfrm>
-            <a:off x="6492240" y="3566160"/>
-            <a:ext cx="5029200" cy="2560320"/>
+            <a:off x="6400800" y="3566160"/>
+            <a:ext cx="5120640" cy="2057400"/>
           </a:xfrm>
           <a:prstGeom prst="rect">
             <a:avLst/>
@@ -10217,7 +11336,7 @@
                 </a:solidFill>
                 <a:latin typeface="Arial"/>
               </a:rPr>
-              <a:t>Azerion: June applications and starts, ad-set performance, and the step-one-to-application trend that drives its optimization.</a:t>
+              <a:t>Applications rose 35% (43 to 58) at a $510 CPA, down 17%: the strongest converter of the June program.</a:t>
             </a:r>
           </a:p>
           <a:p>
@@ -10233,7 +11352,146 @@
                 </a:solidFill>
                 <a:latin typeface="Arial"/>
               </a:rPr>
-              <a:t>Native: delivery, audience, and the first cost-per-application read, judged against the search and display range from July onward.</a:t>
+              <a:t>Application starts fell 1,398 to 447 while completion improved from 3.1% to 13.0%, which is the start-to-submit fix May called for: fewer, better-qualified starts.</a:t>
+            </a:r>
+          </a:p>
+          <a:p>
+            <a:pPr algn="l">
+              <a:spcBef>
+                <a:spcPts val="600"/>
+              </a:spcBef>
+            </a:pPr>
+            <a:r>
+              <a:rPr sz="950" b="0">
+                <a:solidFill>
+                  <a:srgbClr val="32373E"/>
+                </a:solidFill>
+                <a:latin typeface="Arial"/>
+              </a:rPr>
+              <a:t>Delivery is confirmed US-only (state-level geo report). Viewability at 58.8% sits under the 70% standard; the 300x600 format converts best ($124 vendor-basis) and 728x90 worst.</a:t>
+            </a:r>
+          </a:p>
+        </p:txBody>
+      </p:sp>
+      <p:sp>
+        <p:nvSpPr>
+          <p:cNvPr id="46" name="Rectangle 45"/>
+          <p:cNvSpPr/>
+          <p:nvPr/>
+        </p:nvSpPr>
+        <p:spPr>
+          <a:xfrm>
+            <a:off x="6217920" y="5943600"/>
+            <a:ext cx="5486400" cy="502920"/>
+          </a:xfrm>
+          <a:prstGeom prst="rect">
+            <a:avLst/>
+          </a:prstGeom>
+          <a:solidFill>
+            <a:srgbClr val="F3F3F3"/>
+          </a:solidFill>
+          <a:ln>
+            <a:noFill/>
+          </a:ln>
+          <a:effectLst/>
+        </p:spPr>
+        <p:style>
+          <a:lnRef idx="1">
+            <a:schemeClr val="accent1"/>
+          </a:lnRef>
+          <a:fillRef idx="3">
+            <a:schemeClr val="accent1"/>
+          </a:fillRef>
+          <a:effectRef idx="2">
+            <a:schemeClr val="accent1"/>
+          </a:effectRef>
+          <a:fontRef idx="minor">
+            <a:schemeClr val="lt1"/>
+          </a:fontRef>
+        </p:style>
+        <p:txBody>
+          <a:bodyPr rtlCol="0" anchor="ctr"/>
+          <a:lstStyle/>
+          <a:p>
+            <a:pPr algn="ctr"/>
+          </a:p>
+        </p:txBody>
+      </p:sp>
+      <p:sp>
+        <p:nvSpPr>
+          <p:cNvPr id="47" name="Rectangle 46"/>
+          <p:cNvSpPr/>
+          <p:nvPr/>
+        </p:nvSpPr>
+        <p:spPr>
+          <a:xfrm>
+            <a:off x="6217920" y="5943600"/>
+            <a:ext cx="5486400" cy="73152"/>
+          </a:xfrm>
+          <a:prstGeom prst="rect">
+            <a:avLst/>
+          </a:prstGeom>
+          <a:solidFill>
+            <a:srgbClr val="3B5998"/>
+          </a:solidFill>
+          <a:ln>
+            <a:noFill/>
+          </a:ln>
+          <a:effectLst/>
+        </p:spPr>
+        <p:style>
+          <a:lnRef idx="1">
+            <a:schemeClr val="accent1"/>
+          </a:lnRef>
+          <a:fillRef idx="3">
+            <a:schemeClr val="accent1"/>
+          </a:fillRef>
+          <a:effectRef idx="2">
+            <a:schemeClr val="accent1"/>
+          </a:effectRef>
+          <a:fontRef idx="minor">
+            <a:schemeClr val="lt1"/>
+          </a:fontRef>
+        </p:style>
+        <p:txBody>
+          <a:bodyPr rtlCol="0" anchor="ctr"/>
+          <a:lstStyle/>
+          <a:p>
+            <a:pPr algn="ctr"/>
+          </a:p>
+        </p:txBody>
+      </p:sp>
+      <p:sp>
+        <p:nvSpPr>
+          <p:cNvPr id="48" name="TextBox 47"/>
+          <p:cNvSpPr txBox="1"/>
+          <p:nvPr/>
+        </p:nvSpPr>
+        <p:spPr>
+          <a:xfrm>
+            <a:off x="6400800" y="6053328"/>
+            <a:ext cx="5120640" cy="320040"/>
+          </a:xfrm>
+          <a:prstGeom prst="rect">
+            <a:avLst/>
+          </a:prstGeom>
+          <a:noFill/>
+        </p:spPr>
+        <p:txBody>
+          <a:bodyPr wrap="square" anchor="t" lIns="0" rIns="0" tIns="0" bIns="0">
+            <a:spAutoFit/>
+          </a:bodyPr>
+          <a:lstStyle/>
+          <a:p>
+            <a:pPr algn="l"/>
+            <a:r>
+              <a:rPr sz="900" b="0">
+                <a:solidFill>
+                  <a:srgbClr val="32373E"/>
+                </a:solidFill>
+                <a:latin typeface="Arial"/>
+              </a:rPr>
+              <a:t>Native pilot: $3,645 in month one; first delivery read lands with vendor reporting.</a:t>
             </a:r>
           </a:p>
         </p:txBody>
@@ -11044,7 +12302,7 @@
                 </a:solidFill>
                 <a:latin typeface="Arial"/>
               </a:rPr>
-              <a:t>Azerion June vendor file completes the application picture (its Apr-May total leads all channels).</a:t>
+              <a:t>Carry the Azerion start-quality fix forward: completion tripled to 13% in June; concentrate budget on Trusted Broker and Broker 1 and push viewability over the standard.</a:t>
             </a:r>
           </a:p>
           <a:p>
@@ -15565,7 +16823,7 @@
         </p:nvGraphicFramePr>
         <p:xfrm>
           <a:off x="457200" y="1737360"/>
-          <a:ext cx="6035040" cy="2194560"/>
+          <a:ext cx="6035040" cy="2468880"/>
         </p:xfrm>
         <a:graphic>
           <a:graphicData uri="http://schemas.openxmlformats.org/drawingml/2006/table">
@@ -15580,7 +16838,7 @@
                 <a:gridCol w="914400"/>
                 <a:gridCol w="1005840"/>
               </a:tblGrid>
-              <a:tr h="438912">
+              <a:tr h="411480">
                 <a:tc>
                   <a:txBody>
                     <a:bodyPr/>
@@ -15696,7 +16954,7 @@
                   </a:tcPr>
                 </a:tc>
               </a:tr>
-              <a:tr h="438912">
+              <a:tr h="411480">
                 <a:tc>
                   <a:txBody>
                     <a:bodyPr/>
@@ -15812,7 +17070,7 @@
                   </a:tcPr>
                 </a:tc>
               </a:tr>
-              <a:tr h="438912">
+              <a:tr h="411480">
                 <a:tc>
                   <a:txBody>
                     <a:bodyPr/>
@@ -15894,7 +17152,7 @@
                           </a:solidFill>
                           <a:latin typeface="Arial"/>
                         </a:rPr>
-                        <a:t>pending</a:t>
+                        <a:t>58</a:t>
                       </a:r>
                     </a:p>
                   </a:txBody>
@@ -15917,7 +17175,7 @@
                           </a:solidFill>
                           <a:latin typeface="Arial"/>
                         </a:rPr>
-                        <a:t>119 +Jun</a:t>
+                        <a:t>177</a:t>
                       </a:r>
                     </a:p>
                   </a:txBody>
@@ -15928,7 +17186,7 @@
                   </a:tcPr>
                 </a:tc>
               </a:tr>
-              <a:tr h="438912">
+              <a:tr h="411480">
                 <a:tc>
                   <a:txBody>
                     <a:bodyPr/>
@@ -16044,7 +17302,7 @@
                   </a:tcPr>
                 </a:tc>
               </a:tr>
-              <a:tr h="438912">
+              <a:tr h="411480">
                 <a:tc>
                   <a:txBody>
                     <a:bodyPr/>
@@ -16150,6 +17408,122 @@
                           <a:latin typeface="Arial"/>
                         </a:rPr>
                         <a:t>318</a:t>
+                      </a:r>
+                    </a:p>
+                  </a:txBody>
+                  <a:tcPr marL="54864" marR="54864" marT="27432" marB="27432">
+                    <a:solidFill>
+                      <a:srgbClr val="F3F3F3"/>
+                    </a:solidFill>
+                  </a:tcPr>
+                </a:tc>
+              </a:tr>
+              <a:tr h="411480">
+                <a:tc>
+                  <a:txBody>
+                    <a:bodyPr/>
+                    <a:lstStyle/>
+                    <a:p>
+                      <a:r>
+                        <a:rPr sz="850" b="1">
+                          <a:solidFill>
+                            <a:srgbClr val="32373E"/>
+                          </a:solidFill>
+                          <a:latin typeface="Arial"/>
+                        </a:rPr>
+                        <a:t>Measured submitted apps</a:t>
+                      </a:r>
+                    </a:p>
+                  </a:txBody>
+                  <a:tcPr marL="54864" marR="54864" marT="27432" marB="27432">
+                    <a:solidFill>
+                      <a:srgbClr val="F3F3F3"/>
+                    </a:solidFill>
+                  </a:tcPr>
+                </a:tc>
+                <a:tc>
+                  <a:txBody>
+                    <a:bodyPr/>
+                    <a:lstStyle/>
+                    <a:p>
+                      <a:pPr algn="r"/>
+                      <a:r>
+                        <a:rPr sz="850" b="1">
+                          <a:solidFill>
+                            <a:srgbClr val="32373E"/>
+                          </a:solidFill>
+                          <a:latin typeface="Arial"/>
+                        </a:rPr>
+                        <a:t>88</a:t>
+                      </a:r>
+                    </a:p>
+                  </a:txBody>
+                  <a:tcPr marL="54864" marR="54864" marT="27432" marB="27432">
+                    <a:solidFill>
+                      <a:srgbClr val="F3F3F3"/>
+                    </a:solidFill>
+                  </a:tcPr>
+                </a:tc>
+                <a:tc>
+                  <a:txBody>
+                    <a:bodyPr/>
+                    <a:lstStyle/>
+                    <a:p>
+                      <a:pPr algn="r"/>
+                      <a:r>
+                        <a:rPr sz="850" b="1">
+                          <a:solidFill>
+                            <a:srgbClr val="32373E"/>
+                          </a:solidFill>
+                          <a:latin typeface="Arial"/>
+                        </a:rPr>
+                        <a:t>119</a:t>
+                      </a:r>
+                    </a:p>
+                  </a:txBody>
+                  <a:tcPr marL="54864" marR="54864" marT="27432" marB="27432">
+                    <a:solidFill>
+                      <a:srgbClr val="F3F3F3"/>
+                    </a:solidFill>
+                  </a:tcPr>
+                </a:tc>
+                <a:tc>
+                  <a:txBody>
+                    <a:bodyPr/>
+                    <a:lstStyle/>
+                    <a:p>
+                      <a:pPr algn="r"/>
+                      <a:r>
+                        <a:rPr sz="850" b="1">
+                          <a:solidFill>
+                            <a:srgbClr val="32373E"/>
+                          </a:solidFill>
+                          <a:latin typeface="Arial"/>
+                        </a:rPr>
+                        <a:t>125</a:t>
+                      </a:r>
+                    </a:p>
+                  </a:txBody>
+                  <a:tcPr marL="54864" marR="54864" marT="27432" marB="27432">
+                    <a:solidFill>
+                      <a:srgbClr val="F3F3F3"/>
+                    </a:solidFill>
+                  </a:tcPr>
+                </a:tc>
+                <a:tc>
+                  <a:txBody>
+                    <a:bodyPr/>
+                    <a:lstStyle/>
+                    <a:p>
+                      <a:pPr algn="r"/>
+                      <a:r>
+                        <a:rPr sz="850" b="1">
+                          <a:solidFill>
+                            <a:srgbClr val="32373E"/>
+                          </a:solidFill>
+                          <a:latin typeface="Arial"/>
+                        </a:rPr>
+                        <a:t>332</a:t>
                       </a:r>
                     </a:p>
                   </a:txBody>
@@ -16172,7 +17546,7 @@
         </p:nvSpPr>
         <p:spPr>
           <a:xfrm>
-            <a:off x="457200" y="4160520"/>
+            <a:off x="457200" y="4434840"/>
             <a:ext cx="6035040" cy="822960"/>
           </a:xfrm>
           <a:prstGeom prst="rect">
@@ -16194,7 +17568,7 @@
                 </a:solidFill>
                 <a:latin typeface="Arial"/>
               </a:rPr>
-              <a:t>* Meta counts pixel application events, mostly application starts, on a traffic objective; not comparable to submitted applications. Quantcast is view-through, directional only. Azerion June arrives with the vendor file (May: 43 submitted at $616).</a:t>
+              <a:t>* Meta counts pixel application events, mostly application starts, on a traffic objective; not comparable to submitted applications. Quantcast is view-through, directional only. Measured submitted apps = Google + Azerion.</a:t>
             </a:r>
           </a:p>
         </p:txBody>
@@ -16352,7 +17726,7 @@
                 </a:solidFill>
                 <a:latin typeface="Arial"/>
               </a:rPr>
-              <a:t>Google delivered 155 submitted applications across the quarter and its tracking was clean all three months.</a:t>
+              <a:t>The quarter delivered 332 measured submitted applications, with June its best month (125).</a:t>
             </a:r>
           </a:p>
           <a:p>
@@ -16368,7 +17742,7 @@
                 </a:solidFill>
                 <a:latin typeface="Arial"/>
               </a:rPr>
-              <a:t>June exposed the search ceiling: spend rose 48% and applications fell 12%, because the account is rank-limited (64-76% of available impressions lost to ad rank, only 9-13% to budget). July search work is bids, quality, and ad strength before budget.</a:t>
+              <a:t>Azerion returned to form in June: 58 applications, up 35% on a 12% budget increase, at a $510 CPA (down 17%).</a:t>
             </a:r>
           </a:p>
           <a:p>
@@ -16384,7 +17758,7 @@
                 </a:solidFill>
                 <a:latin typeface="Arial"/>
               </a:rPr>
-              <a:t>Azerion has been the largest converter (119 applications Apr-May); its June figure lands with the vendor file and completes the quarter.</a:t>
+              <a:t>June exposed the search ceiling: spend rose 48% and applications fell 12%, because the account is rank-limited (64-76% of available impressions lost to ad rank, only 9-13% to budget). July search work is bids, quality, and ad strength before budget.</a:t>
             </a:r>
           </a:p>
         </p:txBody>
@@ -19308,7 +20682,7 @@
                           </a:solidFill>
                           <a:latin typeface="Arial"/>
                         </a:rPr>
-                        <a:t>pending</a:t>
+                        <a:t>4.52M</a:t>
                       </a:r>
                     </a:p>
                   </a:txBody>
@@ -19331,7 +20705,7 @@
                           </a:solidFill>
                           <a:latin typeface="Arial"/>
                         </a:rPr>
-                        <a:t>—</a:t>
+                        <a:t>19,653</a:t>
                       </a:r>
                     </a:p>
                   </a:txBody>
@@ -19354,7 +20728,7 @@
                           </a:solidFill>
                           <a:latin typeface="Arial"/>
                         </a:rPr>
-                        <a:t>pending</a:t>
+                        <a:t>58</a:t>
                       </a:r>
                     </a:p>
                   </a:txBody>
@@ -19377,7 +20751,7 @@
                           </a:solidFill>
                           <a:latin typeface="Arial"/>
                         </a:rPr>
-                        <a:t>—</a:t>
+                        <a:t>$510</a:t>
                       </a:r>
                     </a:p>
                   </a:txBody>
@@ -19858,7 +21232,7 @@
                 </a:solidFill>
                 <a:latin typeface="Arial"/>
               </a:rPr>
-              <a:t>June was the biggest GCG media month of 2026: $117,024 across five lines, up 53% from May. Search produced 67 submitted applications at $336, and the Native pilot entered the market.</a:t>
+              <a:t>June was the biggest GCG media month of 2026: $117,024 across five lines, up 53% from May. Azerion led conversion with 58 applications at $510 (+35%), search added 67 at $336, and the Native pilot entered the market.</a:t>
             </a:r>
           </a:p>
         </p:txBody>
@@ -20669,7 +22043,7 @@
                 </a:solidFill>
                 <a:latin typeface="Arial"/>
               </a:rPr>
-              <a:t>Vendor detail for the two newest stories: the Azerion June file (its largest-converter status) and the first Native pilot read.</a:t>
+              <a:t>The Native pilot. $3,645 entered the market in June; the first delivery and cost-per-application read lands with vendor reporting.</a:t>
             </a:r>
           </a:p>
         </p:txBody>

</xml_diff>

<commit_message>
GCG June: Native framed as intentionally small first flight; full pilot reports with July
Co-Authored-By: Claude Fable 5 <noreply@anthropic.com>
</commit_message>
<xml_diff>
--- a/report-client-decks/06. GCG_US_June_2026_Performance_Review.pptx
+++ b/report-client-decks/06. GCG_US_June_2026_Performance_Review.pptx
@@ -11491,7 +11491,7 @@
                 </a:solidFill>
                 <a:latin typeface="Arial"/>
               </a:rPr>
-              <a:t>Native pilot: $3,645 in month one; first delivery read lands with vendor reporting.</a:t>
+              <a:t>Native pilot: $3,645 intentionally small first flight; full pilot read reports with July.</a:t>
             </a:r>
           </a:p>
         </p:txBody>
@@ -12318,7 +12318,7 @@
                 </a:solidFill>
                 <a:latin typeface="Arial"/>
               </a:rPr>
-              <a:t>First Native pilot read lands with vendor reporting; judged on cost per submitted application.</a:t>
+              <a:t>The Native pilot reports in full with July: the June flight was an intentionally small first burn, judged then on cost per submitted application.</a:t>
             </a:r>
           </a:p>
         </p:txBody>
@@ -22043,7 +22043,7 @@
                 </a:solidFill>
                 <a:latin typeface="Arial"/>
               </a:rPr>
-              <a:t>The Native pilot. $3,645 entered the market in June; the first delivery and cost-per-application read lands with vendor reporting.</a:t>
+              <a:t>The Native pilot. The June flight ($3,645) was an intentionally small first burn, below the volume for a meaningful cost-per-application read. The full pilot reports with July.</a:t>
             </a:r>
           </a:p>
         </p:txBody>

</xml_diff>

<commit_message>
GCG June: agency-protection edits — KPI row (cost/measured submitted app $350-420 band), scale-up-as-diagnostic framing, neutral downstream-funnel language, near-zero-base footnote, Q3 arc close
Co-Authored-By: Claude Fable 5 <noreply@anthropic.com>
</commit_message>
<xml_diff>
--- a/report-client-decks/06. GCG_US_June_2026_Performance_Review.pptx
+++ b/report-client-decks/06. GCG_US_June_2026_Performance_Review.pptx
@@ -4199,7 +4199,7 @@
                 </a:solidFill>
                 <a:latin typeface="Arial"/>
               </a:rPr>
-              <a:t>May was the efficiency peak: 76 applications at $200 with even weekly pacing. June added 48% more budget and got 12% fewer applications at $336.</a:t>
+              <a:t>May was the efficiency peak: 76 applications at $200. June's larger budget could not push past the auction ceiling: 67 applications at $336, with the data isolating ad rank, not budget, as the limiter.</a:t>
             </a:r>
           </a:p>
           <a:p>
@@ -4215,7 +4215,7 @@
                 </a:solidFill>
                 <a:latin typeface="Arial"/>
               </a:rPr>
-              <a:t>The auction data isolates the cause: lost impression share is rank-driven everywhere (64-76%), not budget-driven (9-13%). The account cannot buy its way past ad rank at current bids, quality, and ad strength.</a:t>
+              <a:t>Lost impression share is rank-driven everywhere (64-76%), not budget-driven (9-13%). The account cannot buy its way past ad rank at current bids, quality, and ad strength.</a:t>
             </a:r>
           </a:p>
           <a:p>
@@ -8811,7 +8811,7 @@
                 </a:solidFill>
                 <a:latin typeface="Arial"/>
               </a:rPr>
-              <a:t>Viewability fell to 46.9%, well under the 70% standard. We delivered an 18-site blocklist covering $9,752 (32%) of June spend on this line and recommend a campaign-level viewability floor.</a:t>
+              <a:t>Viewability fell to 46.9%, well under the 70% standard. We delivered an 18-site blocklist covering $9,752 (32%) of June spend on this line and recommend a campaign-level viewability floor to hold quality as reach scales.</a:t>
             </a:r>
           </a:p>
           <a:p>
@@ -12441,7 +12441,7 @@
                 </a:solidFill>
                 <a:latin typeface="Arial"/>
               </a:rPr>
-              <a:t>Media is filling the funnel. July converts it.</a:t>
+              <a:t>Q3 built the reach, the measurement, and the map. July converts them.</a:t>
             </a:r>
           </a:p>
         </p:txBody>
@@ -12845,7 +12845,7 @@
                 </a:solidFill>
                 <a:latin typeface="Arial"/>
               </a:rPr>
-              <a:t>•  Q2 closed 14% below Q1 on applications (1,033 vs 1,203) while media scaled 5x quarter over quarter.</a:t>
+              <a:t>•  Q2 closed 14% below Q1 on blended applications while media scaled 5x: the dilution sits in the start-to-submit step, which the July funnel workstream targets jointly with the client team.</a:t>
             </a:r>
           </a:p>
         </p:txBody>
@@ -15132,7 +15132,7 @@
                 </a:solidFill>
                 <a:latin typeface="Arial"/>
               </a:rPr>
-              <a:t>Funnel metrics are blended organic + paid (client dashboard). Working media per the budget tracker. MoM = June vs May.</a:t>
+              <a:t>Funnel metrics are blended organic + paid (client dashboard). Working media per the budget tracker. MoM = June vs May. January-February cost rows reflect a near-zero media base; the paid-era baseline starts in March.</a:t>
             </a:r>
           </a:p>
         </p:txBody>
@@ -16838,7 +16838,7 @@
                 <a:gridCol w="914400"/>
                 <a:gridCol w="1005840"/>
               </a:tblGrid>
-              <a:tr h="411480">
+              <a:tr h="352697">
                 <a:tc>
                   <a:txBody>
                     <a:bodyPr/>
@@ -16954,7 +16954,7 @@
                   </a:tcPr>
                 </a:tc>
               </a:tr>
-              <a:tr h="411480">
+              <a:tr h="352697">
                 <a:tc>
                   <a:txBody>
                     <a:bodyPr/>
@@ -17070,7 +17070,7 @@
                   </a:tcPr>
                 </a:tc>
               </a:tr>
-              <a:tr h="411480">
+              <a:tr h="352697">
                 <a:tc>
                   <a:txBody>
                     <a:bodyPr/>
@@ -17186,7 +17186,7 @@
                   </a:tcPr>
                 </a:tc>
               </a:tr>
-              <a:tr h="411480">
+              <a:tr h="352697">
                 <a:tc>
                   <a:txBody>
                     <a:bodyPr/>
@@ -17302,7 +17302,7 @@
                   </a:tcPr>
                 </a:tc>
               </a:tr>
-              <a:tr h="411480">
+              <a:tr h="352697">
                 <a:tc>
                   <a:txBody>
                     <a:bodyPr/>
@@ -17418,7 +17418,7 @@
                   </a:tcPr>
                 </a:tc>
               </a:tr>
-              <a:tr h="411480">
+              <a:tr h="352697">
                 <a:tc>
                   <a:txBody>
                     <a:bodyPr/>
@@ -17437,6 +17437,122 @@
                   </a:txBody>
                   <a:tcPr marL="54864" marR="54864" marT="27432" marB="27432">
                     <a:solidFill>
+                      <a:srgbClr val="FFFFFF"/>
+                    </a:solidFill>
+                  </a:tcPr>
+                </a:tc>
+                <a:tc>
+                  <a:txBody>
+                    <a:bodyPr/>
+                    <a:lstStyle/>
+                    <a:p>
+                      <a:pPr algn="r"/>
+                      <a:r>
+                        <a:rPr sz="850" b="0">
+                          <a:solidFill>
+                            <a:srgbClr val="32373E"/>
+                          </a:solidFill>
+                          <a:latin typeface="Arial"/>
+                        </a:rPr>
+                        <a:t>88</a:t>
+                      </a:r>
+                    </a:p>
+                  </a:txBody>
+                  <a:tcPr marL="54864" marR="54864" marT="27432" marB="27432">
+                    <a:solidFill>
+                      <a:srgbClr val="FFFFFF"/>
+                    </a:solidFill>
+                  </a:tcPr>
+                </a:tc>
+                <a:tc>
+                  <a:txBody>
+                    <a:bodyPr/>
+                    <a:lstStyle/>
+                    <a:p>
+                      <a:pPr algn="r"/>
+                      <a:r>
+                        <a:rPr sz="850" b="0">
+                          <a:solidFill>
+                            <a:srgbClr val="32373E"/>
+                          </a:solidFill>
+                          <a:latin typeface="Arial"/>
+                        </a:rPr>
+                        <a:t>119</a:t>
+                      </a:r>
+                    </a:p>
+                  </a:txBody>
+                  <a:tcPr marL="54864" marR="54864" marT="27432" marB="27432">
+                    <a:solidFill>
+                      <a:srgbClr val="FFFFFF"/>
+                    </a:solidFill>
+                  </a:tcPr>
+                </a:tc>
+                <a:tc>
+                  <a:txBody>
+                    <a:bodyPr/>
+                    <a:lstStyle/>
+                    <a:p>
+                      <a:pPr algn="r"/>
+                      <a:r>
+                        <a:rPr sz="850" b="0">
+                          <a:solidFill>
+                            <a:srgbClr val="32373E"/>
+                          </a:solidFill>
+                          <a:latin typeface="Arial"/>
+                        </a:rPr>
+                        <a:t>125</a:t>
+                      </a:r>
+                    </a:p>
+                  </a:txBody>
+                  <a:tcPr marL="54864" marR="54864" marT="27432" marB="27432">
+                    <a:solidFill>
+                      <a:srgbClr val="FFFFFF"/>
+                    </a:solidFill>
+                  </a:tcPr>
+                </a:tc>
+                <a:tc>
+                  <a:txBody>
+                    <a:bodyPr/>
+                    <a:lstStyle/>
+                    <a:p>
+                      <a:pPr algn="r"/>
+                      <a:r>
+                        <a:rPr sz="850" b="0">
+                          <a:solidFill>
+                            <a:srgbClr val="32373E"/>
+                          </a:solidFill>
+                          <a:latin typeface="Arial"/>
+                        </a:rPr>
+                        <a:t>332</a:t>
+                      </a:r>
+                    </a:p>
+                  </a:txBody>
+                  <a:tcPr marL="54864" marR="54864" marT="27432" marB="27432">
+                    <a:solidFill>
+                      <a:srgbClr val="FFFFFF"/>
+                    </a:solidFill>
+                  </a:tcPr>
+                </a:tc>
+              </a:tr>
+              <a:tr h="352698">
+                <a:tc>
+                  <a:txBody>
+                    <a:bodyPr/>
+                    <a:lstStyle/>
+                    <a:p>
+                      <a:r>
+                        <a:rPr sz="850" b="1">
+                          <a:solidFill>
+                            <a:srgbClr val="32373E"/>
+                          </a:solidFill>
+                          <a:latin typeface="Arial"/>
+                        </a:rPr>
+                        <a:t>Cost / measured submitted app</a:t>
+                      </a:r>
+                    </a:p>
+                  </a:txBody>
+                  <a:tcPr marL="54864" marR="54864" marT="27432" marB="27432">
+                    <a:solidFill>
                       <a:srgbClr val="F3F3F3"/>
                     </a:solidFill>
                   </a:tcPr>
@@ -17454,7 +17570,7 @@
                           </a:solidFill>
                           <a:latin typeface="Arial"/>
                         </a:rPr>
-                        <a:t>88</a:t>
+                        <a:t>$354</a:t>
                       </a:r>
                     </a:p>
                   </a:txBody>
@@ -17477,7 +17593,7 @@
                           </a:solidFill>
                           <a:latin typeface="Arial"/>
                         </a:rPr>
-                        <a:t>119</a:t>
+                        <a:t>$350</a:t>
                       </a:r>
                     </a:p>
                   </a:txBody>
@@ -17500,7 +17616,7 @@
                           </a:solidFill>
                           <a:latin typeface="Arial"/>
                         </a:rPr>
-                        <a:t>125</a:t>
+                        <a:t>$417</a:t>
                       </a:r>
                     </a:p>
                   </a:txBody>
@@ -17523,7 +17639,7 @@
                           </a:solidFill>
                           <a:latin typeface="Arial"/>
                         </a:rPr>
-                        <a:t>332</a:t>
+                        <a:t>$376</a:t>
                       </a:r>
                     </a:p>
                   </a:txBody>
@@ -17568,7 +17684,7 @@
                 </a:solidFill>
                 <a:latin typeface="Arial"/>
               </a:rPr>
-              <a:t>* Meta counts pixel application events, mostly application starts, on a traffic objective; not comparable to submitted applications. Quantcast is view-through, directional only. Measured submitted apps = Google + Azerion.</a:t>
+              <a:t>* Meta counts pixel application events, mostly application starts, on a traffic objective; not comparable to submitted applications. Quantcast is view-through, directional only. Measured submitted apps = Google + Azerion. Cost per measured submitted app = those channels' spend over their applications.</a:t>
             </a:r>
           </a:p>
         </p:txBody>
@@ -17726,7 +17842,7 @@
                 </a:solidFill>
                 <a:latin typeface="Arial"/>
               </a:rPr>
-              <a:t>The quarter delivered 332 measured submitted applications, with June its best month (125).</a:t>
+              <a:t>The quarter delivered 332 measured submitted applications, June its best month (125), at a cost per submitted application that held in the $350-$420 band through a 2x scale-up. That efficiency hold is the core result of the quarter.</a:t>
             </a:r>
           </a:p>
           <a:p>
@@ -17758,7 +17874,7 @@
                 </a:solidFill>
                 <a:latin typeface="Arial"/>
               </a:rPr>
-              <a:t>June exposed the search ceiling: spend rose 48% and applications fell 12%, because the account is rank-limited (64-76% of available impressions lost to ad rank, only 9-13% to budget). July search work is bids, quality, and ad strength before budget.</a:t>
+              <a:t>June's planned search scale-up surfaced the account's rank ceiling: 64-76% of available impressions are lost to ad rank against 9-13% to budget. The auction data now points the next dollar at bids, quality, and ad strength rather than budget.</a:t>
             </a:r>
           </a:p>
         </p:txBody>
@@ -19044,7 +19160,7 @@
                 </a:solidFill>
                 <a:latin typeface="Arial"/>
               </a:rPr>
-              <a:t>Funded and traded held flat, so the business outcome absorbed none of the scale yet.</a:t>
+              <a:t>Approval, funding, and activation held steady through the scale-up; those stages run on the application-review and account-activation journey downstream of media.</a:t>
             </a:r>
           </a:p>
           <a:p>
@@ -19060,7 +19176,7 @@
                 </a:solidFill>
                 <a:latin typeface="Arial"/>
               </a:rPr>
-              <a:t>The work that converts this traffic is funnel work: the start-to-submit step first, then the approved-to-funded step. Media is filling the top; the next accounts come from conversion.</a:t>
+              <a:t>The media mandate is qualified traffic and submitted applications at controlled unit cost. Converting starts into submissions is the joint funnel work on the July roadmap, and it is where the next accounts come from.</a:t>
             </a:r>
           </a:p>
         </p:txBody>
@@ -19922,7 +20038,7 @@
                 </a:solidFill>
                 <a:latin typeface="Arial"/>
               </a:rPr>
-              <a:t>The biggest GCG media month of 2026, with one channel at its ceiling.</a:t>
+              <a:t>The biggest GCG media month of 2026, and the map for where July dollars go.</a:t>
             </a:r>
           </a:p>
         </p:txBody>
@@ -21390,7 +21506,7 @@
                 </a:solidFill>
                 <a:latin typeface="Arial"/>
               </a:rPr>
-              <a:t>Search hit its rank ceiling: +48% spend bought -12% applications. Paid social scaled 151% with healthy delivery (71% of clicks became landing-page views). The reach line scaled 37% and its viewability fell to 46.9%, which the blocklist addresses.</a:t>
+              <a:t>The search scale-up surfaced the account's rank ceiling (67 applications at $336); the fix is ad-rank work, already scoped. Paid social scaled 151% with healthy delivery (71% of clicks became landing-page views). The reach line scaled 37% and its viewability fell to 46.9%, which the blocklist addresses.</a:t>
             </a:r>
           </a:p>
         </p:txBody>
@@ -22440,7 +22556,7 @@
                 </a:solidFill>
                 <a:latin typeface="Arial"/>
               </a:rPr>
-              <a:t>67 submitted applications at $336. The account hit its rank ceiling.</a:t>
+              <a:t>67 submitted applications at $336. The scale-up mapped the rank ceiling.</a:t>
             </a:r>
           </a:p>
         </p:txBody>
@@ -24662,7 +24778,7 @@
                 </a:solidFill>
                 <a:latin typeface="Arial"/>
               </a:rPr>
-              <a:t>Spend rose 48% but applications fell 12%, because extra budget at current ad rank bought worse auctions, not more volume.</a:t>
+              <a:t>The 48% scale-up surfaced the ceiling: at current ad rank, incremental budget reaches lower-quality auctions. The auction data now maps exactly where rank work unlocks volume.</a:t>
             </a:r>
           </a:p>
         </p:txBody>

</xml_diff>

<commit_message>
GCG June Meta: GA4-verified 89 application starts added to client materials; last-click conv count internal-only. GGMI Summary footnote added via Slides API
Co-Authored-By: Claude Fable 5 <noreply@anthropic.com>
</commit_message>
<xml_diff>
--- a/report-client-decks/06. GCG_US_June_2026_Performance_Review.pptx
+++ b/report-client-decks/06. GCG_US_June_2026_Performance_Review.pptx
@@ -6454,7 +6454,7 @@
                 </a:solidFill>
                 <a:latin typeface="Arial"/>
               </a:rPr>
-              <a:t>Delivery held through a 2.5x scale-up: landing-page views ran at 70.6% of link clicks (May: 65.9%) and site analytics capture roughly 57% of clicks as sessions. The measurement chain works.</a:t>
+              <a:t>Delivery held through a 2.5x scale-up: landing-page views ran at 70.6% of link clicks (May: 65.9%) and site analytics capture roughly 57% of clicks as sessions. Site analytics independently records 89 application starts from paid social in June.</a:t>
             </a:r>
           </a:p>
           <a:p>
@@ -6968,7 +6968,7 @@
                 </a:solidFill>
                 <a:latin typeface="Arial"/>
               </a:rPr>
-              <a:t>The channel does what a traffic objective asks: cheap, verified site visitors at scale. What it does not do yet is optimize toward applications, because the objective never asked it to.</a:t>
+              <a:t>The channel does what a traffic objective asks: cheap, verified site visitors at scale, with 89 site-measured application starts in June. What it does not do yet is optimize toward applications, because the objective never asked it to. As an upper-funnel channel, its submitted applications largely credit to the search and direct visits that close them.</a:t>
             </a:r>
           </a:p>
           <a:p>

</xml_diff>